<commit_message>
docs: publish DDS-8555 assignment 8 deliverables
</commit_message>
<xml_diff>
--- a/Week 8/Assignment 8/MaldonadoJDDS8555-8.pptx
+++ b/Week 8/Assignment 8/MaldonadoJDDS8555-8.pptx
@@ -4423,7 +4423,7 @@
               </a:defRPr>
             </a:pPr>
             <a:r>
-              <a:t>ETS produced the stronger public score than ARIMA.</a:t>
+              <a:t>ETS produced the stronger forecast than ARIMA.</a:t>
             </a:r>
           </a:p>
         </p:txBody>
@@ -4503,7 +4503,7 @@
               </a:defRPr>
             </a:pPr>
             <a:r>
-              <a:t>ETS public score: 0.62223</a:t>
+              <a:t>Holdout sMAPE: ETS 0.0704 vs ARIMA 0.0751</a:t>
             </a:r>
           </a:p>
         </p:txBody>
@@ -4583,7 +4583,7 @@
               </a:defRPr>
             </a:pPr>
             <a:r>
-              <a:t>ARIMA public score: 0.64770</a:t>
+              <a:t>Public score: ETS 0.62223 vs ARIMA 0.64770</a:t>
             </a:r>
           </a:p>
         </p:txBody>
@@ -4663,7 +4663,7 @@
               </a:defRPr>
             </a:pPr>
             <a:r>
-              <a:t>Forecasts were allocated from family totals to store-family rows.</a:t>
+              <a:t>Residual bursts suggest holiday and promotion effects remain.</a:t>
             </a:r>
           </a:p>
         </p:txBody>
@@ -4829,7 +4829,7 @@
               </a:defRPr>
             </a:pPr>
             <a:r>
-              <a:t>Gradient boosting handled nonlinear housing effects better than ridge.</a:t>
+              <a:t>Gradient boosting won on Kaggle, while ridge stayed useful as the interpretable benchmark.</a:t>
             </a:r>
           </a:p>
         </p:txBody>
@@ -5069,7 +5069,7 @@
               </a:defRPr>
             </a:pPr>
             <a:r>
-              <a:t>Feature work included indicators, interactions, transformations, and dimension reduction.</a:t>
+              <a:t>Feature work included indicators, interactions, transformations, polynomial terms, subsets, and SVD.</a:t>
             </a:r>
           </a:p>
         </p:txBody>
@@ -5235,7 +5235,7 @@
               </a:defRPr>
             </a:pPr>
             <a:r>
-              <a:t>Random forest was the strongest crime classifier among the submitted models.</a:t>
+              <a:t>Random forest was the strongest submitted classifier.</a:t>
             </a:r>
           </a:p>
         </p:txBody>
@@ -5721,7 +5721,7 @@
               </a:defRPr>
             </a:pPr>
             <a:r>
-              <a:t>Forecasting: time order, residual structure, seasonality.</a:t>
+              <a:t>Forecasting: time order, holdout behavior, residual structure.</a:t>
             </a:r>
           </a:p>
         </p:txBody>
@@ -5801,7 +5801,7 @@
               </a:defRPr>
             </a:pPr>
             <a:r>
-              <a:t>Regression: collinearity, transformation fit, validation error.</a:t>
+              <a:t>Regression: target skew, missingness, subset sensitivity, dimension reduction.</a:t>
             </a:r>
           </a:p>
         </p:txBody>
@@ -5881,7 +5881,7 @@
               </a:defRPr>
             </a:pPr>
             <a:r>
-              <a:t>Classification: imbalance, calibration, held-out accuracy/log loss.</a:t>
+              <a:t>Classification: class imbalance, macro F1, probability quality.</a:t>
             </a:r>
           </a:p>
         </p:txBody>
@@ -6127,7 +6127,7 @@
               </a:defRPr>
             </a:pPr>
             <a:r>
-              <a:t>6 Abalone regression submissions across Weeks 2-4.</a:t>
+              <a:t>2 Store Sales forecasts: ETS and ARIMA.</a:t>
             </a:r>
           </a:p>
         </p:txBody>
@@ -6207,7 +6207,7 @@
               </a:defRPr>
             </a:pPr>
             <a:r>
-              <a:t>8 Obesity classification submissions across Weeks 5-6.</a:t>
+              <a:t>2 House Prices regressions: ridge and gradient boosting.</a:t>
             </a:r>
           </a:p>
         </p:txBody>
@@ -6287,7 +6287,7 @@
               </a:defRPr>
             </a:pPr>
             <a:r>
-              <a:t>7 signature assignment submissions across Store, House, and SF Crime.</a:t>
+              <a:t>3 SF Crime classifiers: decision tree, random forest, linear SVM.</a:t>
             </a:r>
           </a:p>
         </p:txBody>

</xml_diff>